<commit_message>
11장: 삭제된 전복죽 ADVoost ROAS 156% → 157% (원본 156.7% 반올림)
애셋그룹·GFA 일별·SA 일별·키워드 원본으로 본문 숫자 전체 대조 완료

Co-Authored-By: Claude Opus 5.5 <noreply@anthropic.com>
Claude-Session: https://claude.ai/code/session_01QhaMXLZSP9pGCKmVQwpJJs
</commit_message>
<xml_diff>
--- a/bravecompany/브레이브컴퍼니_네이버광고_진단_제안서.pptx
+++ b/bravecompany/브레이브컴퍼니_네이버광고_진단_제안서.pptx
@@ -132,13 +132,13 @@
   <p:extLst>
     <p:ext uri="{521415D9-36F7-43E2-AB2F-B90AF26B5E84}">
       <p14:sectionLst xmlns:p14="http://schemas.microsoft.com/office/powerpoint/2010/main">
-        <p14:section name="표지" id="{cd8c15ea-e57b-6a84-24d9-2f79e3c32599}">
+        <p14:section name="표지" id="{e089350c-990d-fa35-86fc-fb33a35004ce}">
           <p14:sldIdLst>
             <p14:sldId id="256"/>
             <p14:sldId id="257"/>
           </p14:sldIdLst>
         </p14:section>
-        <p14:section name="01 진단 요약" id="{09b21ffc-c068-4ef4-b3dd-a09db63c0575}">
+        <p14:section name="01 진단 요약" id="{282e7499-a50b-cb51-7781-8be9c2849010}">
           <p14:sldIdLst>
             <p14:sldId id="258"/>
             <p14:sldId id="259"/>
@@ -146,7 +146,7 @@
             <p14:sldId id="261"/>
           </p14:sldIdLst>
         </p14:section>
-        <p14:section name="02 검색광고" id="{d53c19ad-39fe-e77a-e9e9-cc2b6e7e31b5}">
+        <p14:section name="02 검색광고" id="{8ceca181-3ed5-a22d-a9d4-fb16eda65ae1}">
           <p14:sldIdLst>
             <p14:sldId id="262"/>
             <p14:sldId id="263"/>
@@ -157,7 +157,7 @@
             <p14:sldId id="268"/>
           </p14:sldIdLst>
         </p14:section>
-        <p14:section name="03 GFA" id="{13851d47-eb74-c1f3-c43b-793d79655aec}">
+        <p14:section name="03 GFA" id="{386919c3-5807-9192-b354-a0509e61c76e}">
           <p14:sldIdLst>
             <p14:sldId id="269"/>
             <p14:sldId id="270"/>
@@ -165,7 +165,7 @@
             <p14:sldId id="272"/>
           </p14:sldIdLst>
         </p14:section>
-        <p14:section name="04 개선 제안" id="{ff1ef5f7-1c2b-b7e0-4faa-6492025c389f}">
+        <p14:section name="04 개선 제안" id="{4583baa5-e624-b37a-042d-fe9242c84c14}">
           <p14:sldIdLst>
             <p14:sldId id="273"/>
             <p14:sldId id="274"/>
@@ -174,7 +174,7 @@
             <p14:sldId id="277"/>
           </p14:sldIdLst>
         </p14:section>
-        <p14:section name="부록" id="{aefbdf82-857f-c861-aae4-2fa5b37cc27f}">
+        <p14:section name="부록" id="{743408d7-d51c-991e-714c-71c42bce1caa}">
           <p14:sldIdLst>
             <p14:sldId id="278"/>
             <p14:sldId id="279"/>
@@ -12425,7 +12425,7 @@
                   <a:schemeClr val="accent2"/>
                 </a:solidFill>
               </a:rPr>
-              <a:t>삭제된 통영숙수 전복죽 ADVoost 2개 (네이버·자사몰): 209만 원, ROAS 156%</a:t>
+              <a:t>삭제된 통영숙수 전복죽 ADVoost 2개 (네이버·자사몰): 209만 원, ROAS 157%</a:t>
             </a:r>
             <a:endParaRPr lang="en-US" sz="1400" dirty="0"/>
           </a:p>

</xml_diff>